<commit_message>
Update ML Poster presentation in documentation
</commit_message>
<xml_diff>
--- a/Documentation/ML_Poster.pptx
+++ b/Documentation/ML_Poster.pptx
@@ -1524,7 +1524,7 @@
           <a:p>
             <a:fld id="{C8A432C8-69A7-458B-9684-2BFA64B31948}" type="datetime2">
               <a:rPr lang="en-US" smtClean="0"/>
-              <a:t>Sunday, May 17, 2026</a:t>
+              <a:t>Monday, May 18, 2026</a:t>
             </a:fld>
             <a:endParaRPr lang="en-US"/>
           </a:p>
@@ -1690,7 +1690,7 @@
           <a:p>
             <a:fld id="{8CC057FC-95B6-4D89-AFDA-ABA33EE921E5}" type="datetime2">
               <a:rPr lang="en-US" smtClean="0"/>
-              <a:t>Sunday, May 17, 2026</a:t>
+              <a:t>Monday, May 18, 2026</a:t>
             </a:fld>
             <a:endParaRPr lang="en-US"/>
           </a:p>
@@ -1866,7 +1866,7 @@
           <a:p>
             <a:fld id="{EC4549AC-EB31-477F-92A9-B1988E232878}" type="datetime2">
               <a:rPr lang="en-US" smtClean="0"/>
-              <a:t>Sunday, May 17, 2026</a:t>
+              <a:t>Monday, May 18, 2026</a:t>
             </a:fld>
             <a:endParaRPr lang="en-US"/>
           </a:p>
@@ -2032,7 +2032,7 @@
           <a:p>
             <a:fld id="{6396A3A3-94A6-4E5B-AF39-173ACA3E61CC}" type="datetime2">
               <a:rPr lang="en-US" smtClean="0"/>
-              <a:t>Sunday, May 17, 2026</a:t>
+              <a:t>Monday, May 18, 2026</a:t>
             </a:fld>
             <a:endParaRPr lang="en-US"/>
           </a:p>
@@ -2275,7 +2275,7 @@
           <a:p>
             <a:fld id="{9933D019-A32C-4EAD-B8E6-DBDA699692FD}" type="datetime2">
               <a:rPr lang="en-US" smtClean="0"/>
-              <a:t>Sunday, May 17, 2026</a:t>
+              <a:t>Monday, May 18, 2026</a:t>
             </a:fld>
             <a:endParaRPr lang="en-US"/>
           </a:p>
@@ -2540,7 +2540,7 @@
           <a:p>
             <a:fld id="{CCEBA98F-560C-4997-81C4-81D4D9187EAB}" type="datetime2">
               <a:rPr lang="en-US" smtClean="0"/>
-              <a:t>Sunday, May 17, 2026</a:t>
+              <a:t>Monday, May 18, 2026</a:t>
             </a:fld>
             <a:endParaRPr lang="en-US"/>
           </a:p>
@@ -2919,7 +2919,7 @@
           <a:p>
             <a:fld id="{150972B2-CA5C-437D-87D0-8081271A9E4B}" type="datetime2">
               <a:rPr lang="en-US" smtClean="0"/>
-              <a:t>Sunday, May 17, 2026</a:t>
+              <a:t>Monday, May 18, 2026</a:t>
             </a:fld>
             <a:endParaRPr lang="en-US"/>
           </a:p>
@@ -3070,7 +3070,7 @@
           <a:p>
             <a:fld id="{79CD4847-11EF-4466-A8AD-85CDB7B49118}" type="datetime2">
               <a:rPr lang="en-US" smtClean="0"/>
-              <a:t>Sunday, May 17, 2026</a:t>
+              <a:t>Monday, May 18, 2026</a:t>
             </a:fld>
             <a:endParaRPr lang="en-US"/>
           </a:p>
@@ -3162,7 +3162,7 @@
           <a:p>
             <a:fld id="{F168457A-3AB9-4880-8A0C-9F8524491207}" type="datetime2">
               <a:rPr lang="en-US" smtClean="0"/>
-              <a:t>Sunday, May 17, 2026</a:t>
+              <a:t>Monday, May 18, 2026</a:t>
             </a:fld>
             <a:endParaRPr lang="en-US"/>
           </a:p>
@@ -3424,7 +3424,7 @@
           <a:p>
             <a:fld id="{3FE976D3-5B7F-4300-ABED-C91F1B2AE209}" type="datetime2">
               <a:rPr lang="en-US" smtClean="0"/>
-              <a:t>Sunday, May 17, 2026</a:t>
+              <a:t>Monday, May 18, 2026</a:t>
             </a:fld>
             <a:endParaRPr lang="en-US"/>
           </a:p>
@@ -3713,7 +3713,7 @@
           <a:p>
             <a:fld id="{EBDC1E59-17DD-41CE-97CA-624A472382D4}" type="datetime2">
               <a:rPr lang="en-US" smtClean="0"/>
-              <a:t>Sunday, May 17, 2026</a:t>
+              <a:t>Monday, May 18, 2026</a:t>
             </a:fld>
             <a:endParaRPr lang="en-US"/>
           </a:p>
@@ -4484,7 +4484,7 @@
           <a:p>
             <a:fld id="{A80CB818-7379-467D-8E76-EF9D9074A26C}" type="datetime2">
               <a:rPr lang="en-US" smtClean="0"/>
-              <a:t>Sunday, May 17, 2026</a:t>
+              <a:t>Monday, May 18, 2026</a:t>
             </a:fld>
             <a:endParaRPr lang="en-US" dirty="0"/>
           </a:p>
@@ -5687,8 +5687,8 @@
         </p:nvSpPr>
         <p:spPr>
           <a:xfrm>
-            <a:off x="11682933" y="9386930"/>
-            <a:ext cx="30947912" cy="13563598"/>
+            <a:off x="11682932" y="9386930"/>
+            <a:ext cx="31516358" cy="13451583"/>
           </a:xfrm>
           <a:prstGeom prst="rect">
             <a:avLst/>
@@ -6491,7 +6491,7 @@
         </p:nvSpPr>
         <p:spPr>
           <a:xfrm>
-            <a:off x="30191295" y="10080111"/>
+            <a:off x="30517723" y="10107357"/>
             <a:ext cx="12366836" cy="11726287"/>
           </a:xfrm>
           <a:prstGeom prst="rect">

</xml_diff>